<commit_message>
Set lecturer name on EVM1110E W07–W13 title slides
Co-Authored-By: Claude Opus 5.5 <noreply@anthropic.com>
Claude-Session: https://claude.ai/code/session_014XeJ9qLbTDMocCiAnkJ5Tv
</commit_message>
<xml_diff>
--- a/examples/EVM1110E_W07/EVM1110E_W07_Procurement_Negotiation.pptx
+++ b/examples/EVM1110E_W07/EVM1110E_W07_Procurement_Negotiation.pptx
@@ -532,7 +532,7 @@
           <a:p>
             <a:r>
               <a:rPr lang="en-US" dirty="0"/>
-              <a:t>Slide 1 (dàn ý #1). Điền tên giảng viên trước khi dạy.</a:t>
+              <a:t>Slide 1 (dàn ý #1).</a:t>
             </a:r>
             <a:endParaRPr lang="en-US" dirty="0"/>
           </a:p>
@@ -4239,7 +4239,7 @@
                 <a:ea typeface="Alexandria" pitchFamily="34" charset="-122"/>
                 <a:cs typeface="Alexandria" pitchFamily="34" charset="-120"/>
               </a:rPr>
-              <a:t>Giảng viên: [Tên giảng viên]</a:t>
+              <a:t>Giảng viên: Đoàn Nguyễn Bảo Quyên</a:t>
             </a:r>
             <a:endParaRPr lang="en-US" sz="1500" dirty="0"/>
           </a:p>

</xml_diff>